<commit_message>
Fix: re-render with patched course-creator renderer
The branching-tree layout had a bug where left-side children produced
negative line widths, causing connectors to not render. Fixed by using
Math.abs() for line width calculation in renderer.

- section_02.pptx: re-rendered with fix
- ch02_design_patterns.pptx: updated
- LLM_Agent_Visual_Skill_Design_v2.pptx: re-merged with fixed slides
</commit_message>
<xml_diff>
--- a/LLM_Agent_Visual_Skill_Design_v2.pptx
+++ b/LLM_Agent_Visual_Skill_Design_v2.pptx
@@ -1986,8 +1986,8 @@
         </p:nvSpPr>
         <p:spPr>
           <a:xfrm>
-            <a:off x="4572000" y="2194560"/>
-            <a:ext cx="-2331720" cy="0"/>
+            <a:off x="2240280" y="2194560"/>
+            <a:ext cx="2331720" cy="0"/>
           </a:xfrm>
           <a:prstGeom prst="line">
             <a:avLst/>
@@ -2126,8 +2126,8 @@
         </p:nvSpPr>
         <p:spPr>
           <a:xfrm>
-            <a:off x="4572000" y="2194560"/>
-            <a:ext cx="-777240" cy="0"/>
+            <a:off x="3794760" y="2194560"/>
+            <a:ext cx="777240" cy="0"/>
           </a:xfrm>
           <a:prstGeom prst="line">
             <a:avLst/>

</xml_diff>

<commit_message>
Fix: re-render with comprehensive line-drawing fixes
Updated section_02 and section_06 after fixing course-creator renderer:
- branching-tree: all connector lines now render correctly
- cycle-flow: circular arcs now render as continuous curves
- addArrowConnector: all styles (straight/step/curved) fixed
- addCurvedPath: interpolated segments fixed

All 33 slides verified with 0 negative dimensions.
</commit_message>
<xml_diff>
--- a/LLM_Agent_Visual_Skill_Design_v2.pptx
+++ b/LLM_Agent_Visual_Skill_Design_v2.pptx
@@ -22197,8 +22197,8 @@
         </p:nvSpPr>
         <p:spPr>
           <a:xfrm>
-            <a:off x="6035040" y="3017520"/>
-            <a:ext cx="-28112" cy="285425"/>
+            <a:off x="6006928" y="3017520"/>
+            <a:ext cx="28112" cy="285425"/>
           </a:xfrm>
           <a:prstGeom prst="line">
             <a:avLst/>
@@ -22220,8 +22220,8 @@
         </p:nvSpPr>
         <p:spPr>
           <a:xfrm>
-            <a:off x="6006928" y="3302945"/>
-            <a:ext cx="-83255" cy="274456"/>
+            <a:off x="5923673" y="3302945"/>
+            <a:ext cx="83255" cy="274456"/>
           </a:xfrm>
           <a:prstGeom prst="line">
             <a:avLst/>
@@ -22243,8 +22243,8 @@
         </p:nvSpPr>
         <p:spPr>
           <a:xfrm>
-            <a:off x="5923673" y="3577401"/>
-            <a:ext cx="-135199" cy="252940"/>
+            <a:off x="5788473" y="3577401"/>
+            <a:ext cx="135199" cy="252940"/>
           </a:xfrm>
           <a:prstGeom prst="line">
             <a:avLst/>
@@ -22266,8 +22266,8 @@
         </p:nvSpPr>
         <p:spPr>
           <a:xfrm>
-            <a:off x="5788473" y="3830341"/>
-            <a:ext cx="-181948" cy="221704"/>
+            <a:off x="5606526" y="3830341"/>
+            <a:ext cx="181948" cy="221704"/>
           </a:xfrm>
           <a:prstGeom prst="line">
             <a:avLst/>
@@ -22289,8 +22289,8 @@
         </p:nvSpPr>
         <p:spPr>
           <a:xfrm>
-            <a:off x="5606526" y="4052046"/>
-            <a:ext cx="-221704" cy="181948"/>
+            <a:off x="5384821" y="4052046"/>
+            <a:ext cx="221704" cy="181948"/>
           </a:xfrm>
           <a:prstGeom prst="line">
             <a:avLst/>
@@ -22312,8 +22312,8 @@
         </p:nvSpPr>
         <p:spPr>
           <a:xfrm>
-            <a:off x="5384821" y="4233993"/>
-            <a:ext cx="-252940" cy="135199"/>
+            <a:off x="5131881" y="4233993"/>
+            <a:ext cx="252940" cy="135199"/>
           </a:xfrm>
           <a:prstGeom prst="line">
             <a:avLst/>
@@ -22335,8 +22335,8 @@
         </p:nvSpPr>
         <p:spPr>
           <a:xfrm>
-            <a:off x="5131881" y="4369193"/>
-            <a:ext cx="-274456" cy="83255"/>
+            <a:off x="4857425" y="4369193"/>
+            <a:ext cx="274456" cy="83255"/>
           </a:xfrm>
           <a:prstGeom prst="line">
             <a:avLst/>
@@ -22358,8 +22358,8 @@
         </p:nvSpPr>
         <p:spPr>
           <a:xfrm>
-            <a:off x="4857425" y="4452448"/>
-            <a:ext cx="-285425" cy="28112"/>
+            <a:off x="4572000" y="4452448"/>
+            <a:ext cx="285425" cy="28112"/>
           </a:xfrm>
           <a:prstGeom prst="line">
             <a:avLst/>
@@ -22382,8 +22382,8 @@
         </p:nvSpPr>
         <p:spPr>
           <a:xfrm>
-            <a:off x="4572000" y="4480560"/>
-            <a:ext cx="-285425" cy="-28112"/>
+            <a:off x="4286575" y="4452448"/>
+            <a:ext cx="285425" cy="28112"/>
           </a:xfrm>
           <a:prstGeom prst="line">
             <a:avLst/>
@@ -22405,8 +22405,8 @@
         </p:nvSpPr>
         <p:spPr>
           <a:xfrm>
-            <a:off x="4286575" y="4452448"/>
-            <a:ext cx="-274456" cy="-83255"/>
+            <a:off x="4012119" y="4369193"/>
+            <a:ext cx="274456" cy="83255"/>
           </a:xfrm>
           <a:prstGeom prst="line">
             <a:avLst/>
@@ -22428,8 +22428,8 @@
         </p:nvSpPr>
         <p:spPr>
           <a:xfrm>
-            <a:off x="4012119" y="4369193"/>
-            <a:ext cx="-252940" cy="-135199"/>
+            <a:off x="3759179" y="4233993"/>
+            <a:ext cx="252940" cy="135199"/>
           </a:xfrm>
           <a:prstGeom prst="line">
             <a:avLst/>
@@ -22451,8 +22451,8 @@
         </p:nvSpPr>
         <p:spPr>
           <a:xfrm>
-            <a:off x="3759179" y="4233993"/>
-            <a:ext cx="-221704" cy="-181948"/>
+            <a:off x="3537474" y="4052046"/>
+            <a:ext cx="221704" cy="181948"/>
           </a:xfrm>
           <a:prstGeom prst="line">
             <a:avLst/>
@@ -22474,8 +22474,8 @@
         </p:nvSpPr>
         <p:spPr>
           <a:xfrm>
-            <a:off x="3537474" y="4052046"/>
-            <a:ext cx="-181948" cy="-221704"/>
+            <a:off x="3355527" y="3830341"/>
+            <a:ext cx="181948" cy="221704"/>
           </a:xfrm>
           <a:prstGeom prst="line">
             <a:avLst/>
@@ -22497,8 +22497,8 @@
         </p:nvSpPr>
         <p:spPr>
           <a:xfrm>
-            <a:off x="3355527" y="3830341"/>
-            <a:ext cx="-135199" cy="-252940"/>
+            <a:off x="3220327" y="3577401"/>
+            <a:ext cx="135199" cy="252940"/>
           </a:xfrm>
           <a:prstGeom prst="line">
             <a:avLst/>
@@ -22520,8 +22520,8 @@
         </p:nvSpPr>
         <p:spPr>
           <a:xfrm>
-            <a:off x="3220327" y="3577401"/>
-            <a:ext cx="-83255" cy="-274456"/>
+            <a:off x="3137072" y="3302945"/>
+            <a:ext cx="83255" cy="274456"/>
           </a:xfrm>
           <a:prstGeom prst="line">
             <a:avLst/>
@@ -22543,8 +22543,8 @@
         </p:nvSpPr>
         <p:spPr>
           <a:xfrm>
-            <a:off x="3137072" y="3302945"/>
-            <a:ext cx="-28112" cy="-285425"/>
+            <a:off x="3108960" y="3017520"/>
+            <a:ext cx="28112" cy="285425"/>
           </a:xfrm>
           <a:prstGeom prst="line">
             <a:avLst/>
@@ -22567,8 +22567,8 @@
         </p:nvSpPr>
         <p:spPr>
           <a:xfrm>
-            <a:off x="3108960" y="3017520"/>
-            <a:ext cx="28112" cy="-285425"/>
+            <a:off x="3108960" y="2732095"/>
+            <a:ext cx="28112" cy="285425"/>
           </a:xfrm>
           <a:prstGeom prst="line">
             <a:avLst/>
@@ -22590,8 +22590,8 @@
         </p:nvSpPr>
         <p:spPr>
           <a:xfrm>
-            <a:off x="3137072" y="2732095"/>
-            <a:ext cx="83255" cy="-274456"/>
+            <a:off x="3137072" y="2457639"/>
+            <a:ext cx="83255" cy="274456"/>
           </a:xfrm>
           <a:prstGeom prst="line">
             <a:avLst/>
@@ -22613,8 +22613,8 @@
         </p:nvSpPr>
         <p:spPr>
           <a:xfrm>
-            <a:off x="3220327" y="2457639"/>
-            <a:ext cx="135199" cy="-252940"/>
+            <a:off x="3220327" y="2204699"/>
+            <a:ext cx="135199" cy="252940"/>
           </a:xfrm>
           <a:prstGeom prst="line">
             <a:avLst/>
@@ -22636,8 +22636,8 @@
         </p:nvSpPr>
         <p:spPr>
           <a:xfrm>
-            <a:off x="3355527" y="2204699"/>
-            <a:ext cx="181948" cy="-221704"/>
+            <a:off x="3355527" y="1982994"/>
+            <a:ext cx="181948" cy="221704"/>
           </a:xfrm>
           <a:prstGeom prst="line">
             <a:avLst/>
@@ -22659,8 +22659,8 @@
         </p:nvSpPr>
         <p:spPr>
           <a:xfrm>
-            <a:off x="3537474" y="1982994"/>
-            <a:ext cx="221704" cy="-181948"/>
+            <a:off x="3537474" y="1801047"/>
+            <a:ext cx="221704" cy="181948"/>
           </a:xfrm>
           <a:prstGeom prst="line">
             <a:avLst/>
@@ -22682,8 +22682,8 @@
         </p:nvSpPr>
         <p:spPr>
           <a:xfrm>
-            <a:off x="3759179" y="1801047"/>
-            <a:ext cx="252940" cy="-135199"/>
+            <a:off x="3759179" y="1665847"/>
+            <a:ext cx="252940" cy="135199"/>
           </a:xfrm>
           <a:prstGeom prst="line">
             <a:avLst/>
@@ -22705,8 +22705,8 @@
         </p:nvSpPr>
         <p:spPr>
           <a:xfrm>
-            <a:off x="4012119" y="1665847"/>
-            <a:ext cx="274456" cy="-83255"/>
+            <a:off x="4012119" y="1582592"/>
+            <a:ext cx="274456" cy="83255"/>
           </a:xfrm>
           <a:prstGeom prst="line">
             <a:avLst/>
@@ -22728,8 +22728,8 @@
         </p:nvSpPr>
         <p:spPr>
           <a:xfrm>
-            <a:off x="4286575" y="1582592"/>
-            <a:ext cx="285425" cy="-28112"/>
+            <a:off x="4286575" y="1554480"/>
+            <a:ext cx="285425" cy="28112"/>
           </a:xfrm>
           <a:prstGeom prst="line">
             <a:avLst/>

</xml_diff>